<commit_message>
Corrige PPTX: reinsere icones e vetores que faltavam
</commit_message>
<xml_diff>
--- a/dia-d-seguranca-ferroviaria/VLI_Dia_D_Seguranca_Ferroviaria.pptx
+++ b/dia-d-seguranca-ferroviaria/VLI_Dia_D_Seguranca_Ferroviaria.pptx
@@ -4028,15 +4028,39 @@
           </a:effectLst>
         </p:spPr>
       </p:sp>
-      <p:sp>
-        <p:nvSpPr>
-          <p:cNvPr id="18" name="Text 16"/>
-          <p:cNvSpPr/>
-          <p:nvPr/>
-        </p:nvSpPr>
+      <p:pic>
+        <p:nvPicPr>
+          <p:cNvPr id="18" name="Image 0" descr="A:\Programas\PASTAS DO SISTEMA\claude\A--Documentos-Gest-o-de-Demandas\8ed8d158-bafd-4b35-b37c-d76ce293907f\scratchpad\vli-fonts\pptx_icons\share_traz.png">    </p:cNvPr>
+          <p:cNvPicPr>
+            <a:picLocks noChangeAspect="1"/>
+          </p:cNvPicPr>
+          <p:nvPr/>
+        </p:nvPicPr>
+        <p:blipFill>
+          <a:blip r:embed="rId1"/>
+          <a:stretch>
+            <a:fillRect/>
+          </a:stretch>
+        </p:blipFill>
         <p:spPr>
           <a:xfrm>
             <a:off x="704088" y="3044952"/>
+            <a:ext cx="274320" cy="274320"/>
+          </a:xfrm>
+          <a:prstGeom prst="rect">
+            <a:avLst/>
+          </a:prstGeom>
+        </p:spPr>
+      </p:pic>
+      <p:sp>
+        <p:nvSpPr>
+          <p:cNvPr id="19" name="Text 16"/>
+          <p:cNvSpPr/>
+          <p:nvPr/>
+        </p:nvSpPr>
+        <p:spPr>
+          <a:xfrm>
+            <a:off x="704088" y="3383280"/>
             <a:ext cx="3191256" cy="256032"/>
           </a:xfrm>
           <a:prstGeom prst="rect">
@@ -4069,14 +4093,14 @@
       </p:sp>
       <p:sp>
         <p:nvSpPr>
-          <p:cNvPr id="19" name="Text 17"/>
-          <p:cNvSpPr/>
-          <p:nvPr/>
-        </p:nvSpPr>
-        <p:spPr>
-          <a:xfrm>
-            <a:off x="704088" y="3337560"/>
-            <a:ext cx="3191256" cy="1005840"/>
+          <p:cNvPr id="20" name="Text 17"/>
+          <p:cNvSpPr/>
+          <p:nvPr/>
+        </p:nvSpPr>
+        <p:spPr>
+          <a:xfrm>
+            <a:off x="704088" y="3666744"/>
+            <a:ext cx="3191256" cy="685800"/>
           </a:xfrm>
           <a:prstGeom prst="rect">
             <a:avLst/>
@@ -4111,7 +4135,7 @@
       </p:sp>
       <p:sp>
         <p:nvSpPr>
-          <p:cNvPr id="20" name="Shape 18"/>
+          <p:cNvPr id="21" name="Shape 18"/>
           <p:cNvSpPr/>
           <p:nvPr/>
         </p:nvSpPr>
@@ -4138,15 +4162,39 @@
           </a:effectLst>
         </p:spPr>
       </p:sp>
-      <p:sp>
-        <p:nvSpPr>
-          <p:cNvPr id="21" name="Text 19"/>
-          <p:cNvSpPr/>
-          <p:nvPr/>
-        </p:nvSpPr>
+      <p:pic>
+        <p:nvPicPr>
+          <p:cNvPr id="22" name="Image 1" descr="A:\Programas\PASTAS DO SISTEMA\claude\A--Documentos-Gest-o-de-Demandas\8ed8d158-bafd-4b35-b37c-d76ce293907f\scratchpad\vli-fonts\pptx_icons\share_part.png">    </p:cNvPr>
+          <p:cNvPicPr>
+            <a:picLocks noChangeAspect="1"/>
+          </p:cNvPicPr>
+          <p:nvPr/>
+        </p:nvPicPr>
+        <p:blipFill>
+          <a:blip r:embed="rId2"/>
+          <a:stretch>
+            <a:fillRect/>
+          </a:stretch>
+        </p:blipFill>
         <p:spPr>
           <a:xfrm>
             <a:off x="4480560" y="3044952"/>
+            <a:ext cx="274320" cy="274320"/>
+          </a:xfrm>
+          <a:prstGeom prst="rect">
+            <a:avLst/>
+          </a:prstGeom>
+        </p:spPr>
+      </p:pic>
+      <p:sp>
+        <p:nvSpPr>
+          <p:cNvPr id="23" name="Text 19"/>
+          <p:cNvSpPr/>
+          <p:nvPr/>
+        </p:nvSpPr>
+        <p:spPr>
+          <a:xfrm>
+            <a:off x="4480560" y="3383280"/>
             <a:ext cx="3191256" cy="256032"/>
           </a:xfrm>
           <a:prstGeom prst="rect">
@@ -4179,14 +4227,14 @@
       </p:sp>
       <p:sp>
         <p:nvSpPr>
-          <p:cNvPr id="22" name="Text 20"/>
-          <p:cNvSpPr/>
-          <p:nvPr/>
-        </p:nvSpPr>
-        <p:spPr>
-          <a:xfrm>
-            <a:off x="4480560" y="3337560"/>
-            <a:ext cx="3191256" cy="1005840"/>
+          <p:cNvPr id="24" name="Text 20"/>
+          <p:cNvSpPr/>
+          <p:nvPr/>
+        </p:nvSpPr>
+        <p:spPr>
+          <a:xfrm>
+            <a:off x="4480560" y="3666744"/>
+            <a:ext cx="3191256" cy="685800"/>
           </a:xfrm>
           <a:prstGeom prst="rect">
             <a:avLst/>
@@ -4221,7 +4269,7 @@
       </p:sp>
       <p:sp>
         <p:nvSpPr>
-          <p:cNvPr id="23" name="Shape 21"/>
+          <p:cNvPr id="25" name="Shape 21"/>
           <p:cNvSpPr/>
           <p:nvPr/>
         </p:nvSpPr>
@@ -4248,15 +4296,39 @@
           </a:effectLst>
         </p:spPr>
       </p:sp>
-      <p:sp>
-        <p:nvSpPr>
-          <p:cNvPr id="24" name="Text 22"/>
-          <p:cNvSpPr/>
-          <p:nvPr/>
-        </p:nvSpPr>
+      <p:pic>
+        <p:nvPicPr>
+          <p:cNvPr id="26" name="Image 2" descr="A:\Programas\PASTAS DO SISTEMA\claude\A--Documentos-Gest-o-de-Demandas\8ed8d158-bafd-4b35-b37c-d76ce293907f\scratchpad\vli-fonts\pptx_icons\share_prop.png">    </p:cNvPr>
+          <p:cNvPicPr>
+            <a:picLocks noChangeAspect="1"/>
+          </p:cNvPicPr>
+          <p:nvPr/>
+        </p:nvPicPr>
+        <p:blipFill>
+          <a:blip r:embed="rId3"/>
+          <a:stretch>
+            <a:fillRect/>
+          </a:stretch>
+        </p:blipFill>
         <p:spPr>
           <a:xfrm>
             <a:off x="8257032" y="3044952"/>
+            <a:ext cx="274320" cy="274320"/>
+          </a:xfrm>
+          <a:prstGeom prst="rect">
+            <a:avLst/>
+          </a:prstGeom>
+        </p:spPr>
+      </p:pic>
+      <p:sp>
+        <p:nvSpPr>
+          <p:cNvPr id="27" name="Text 22"/>
+          <p:cNvSpPr/>
+          <p:nvPr/>
+        </p:nvSpPr>
+        <p:spPr>
+          <a:xfrm>
+            <a:off x="8257032" y="3383280"/>
             <a:ext cx="3191256" cy="256032"/>
           </a:xfrm>
           <a:prstGeom prst="rect">
@@ -4289,14 +4361,14 @@
       </p:sp>
       <p:sp>
         <p:nvSpPr>
-          <p:cNvPr id="25" name="Text 23"/>
-          <p:cNvSpPr/>
-          <p:nvPr/>
-        </p:nvSpPr>
-        <p:spPr>
-          <a:xfrm>
-            <a:off x="8257032" y="3337560"/>
-            <a:ext cx="3191256" cy="1005840"/>
+          <p:cNvPr id="28" name="Text 23"/>
+          <p:cNvSpPr/>
+          <p:nvPr/>
+        </p:nvSpPr>
+        <p:spPr>
+          <a:xfrm>
+            <a:off x="8257032" y="3666744"/>
+            <a:ext cx="3191256" cy="685800"/>
           </a:xfrm>
           <a:prstGeom prst="rect">
             <a:avLst/>
@@ -4331,7 +4403,7 @@
       </p:sp>
       <p:sp>
         <p:nvSpPr>
-          <p:cNvPr id="26" name="Shape 24"/>
+          <p:cNvPr id="29" name="Shape 24"/>
           <p:cNvSpPr/>
           <p:nvPr/>
         </p:nvSpPr>
@@ -4353,7 +4425,7 @@
       </p:sp>
       <p:sp>
         <p:nvSpPr>
-          <p:cNvPr id="27" name="Text 25"/>
+          <p:cNvPr id="30" name="Text 25"/>
           <p:cNvSpPr/>
           <p:nvPr/>
         </p:nvSpPr>
@@ -4395,7 +4467,7 @@
       </p:sp>
       <p:sp>
         <p:nvSpPr>
-          <p:cNvPr id="28" name="Text 26"/>
+          <p:cNvPr id="31" name="Text 26"/>
           <p:cNvSpPr/>
           <p:nvPr/>
         </p:nvSpPr>
@@ -4434,7 +4506,7 @@
       </p:sp>
       <p:sp>
         <p:nvSpPr>
-          <p:cNvPr id="29" name="Text 27"/>
+          <p:cNvPr id="32" name="Text 27"/>
           <p:cNvSpPr/>
           <p:nvPr/>
         </p:nvSpPr>
@@ -4656,9 +4728,33 @@
           <a:ln/>
         </p:spPr>
       </p:sp>
-      <p:sp>
-        <p:nvSpPr>
-          <p:cNvPr id="7" name="Text 5"/>
+      <p:pic>
+        <p:nvPicPr>
+          <p:cNvPr id="7" name="Image 0" descr="A:\Programas\PASTAS DO SISTEMA\claude\A--Documentos-Gest-o-de-Demandas\8ed8d158-bafd-4b35-b37c-d76ce293907f\scratchpad\vli-fonts\pptx_icons\pillar_escala.png">    </p:cNvPr>
+          <p:cNvPicPr>
+            <a:picLocks noChangeAspect="1"/>
+          </p:cNvPicPr>
+          <p:nvPr/>
+        </p:nvPicPr>
+        <p:blipFill>
+          <a:blip r:embed="rId1"/>
+          <a:stretch>
+            <a:fillRect/>
+          </a:stretch>
+        </p:blipFill>
+        <p:spPr>
+          <a:xfrm>
+            <a:off x="877824" y="2157984"/>
+            <a:ext cx="256032" cy="256032"/>
+          </a:xfrm>
+          <a:prstGeom prst="rect">
+            <a:avLst/>
+          </a:prstGeom>
+        </p:spPr>
+      </p:pic>
+      <p:sp>
+        <p:nvSpPr>
+          <p:cNvPr id="8" name="Text 5"/>
           <p:cNvSpPr/>
           <p:nvPr/>
         </p:nvSpPr>
@@ -4697,7 +4793,7 @@
       </p:sp>
       <p:sp>
         <p:nvSpPr>
-          <p:cNvPr id="8" name="Text 6"/>
+          <p:cNvPr id="9" name="Text 6"/>
           <p:cNvSpPr/>
           <p:nvPr/>
         </p:nvSpPr>
@@ -4739,7 +4835,7 @@
       </p:sp>
       <p:sp>
         <p:nvSpPr>
-          <p:cNvPr id="9" name="Shape 7"/>
+          <p:cNvPr id="10" name="Shape 7"/>
           <p:cNvSpPr/>
           <p:nvPr/>
         </p:nvSpPr>
@@ -4766,7 +4862,7 @@
       </p:sp>
       <p:sp>
         <p:nvSpPr>
-          <p:cNvPr id="10" name="Shape 8"/>
+          <p:cNvPr id="11" name="Shape 8"/>
           <p:cNvSpPr/>
           <p:nvPr/>
         </p:nvSpPr>
@@ -4786,9 +4882,33 @@
           <a:ln/>
         </p:spPr>
       </p:sp>
-      <p:sp>
-        <p:nvSpPr>
-          <p:cNvPr id="11" name="Text 9"/>
+      <p:pic>
+        <p:nvPicPr>
+          <p:cNvPr id="12" name="Image 1" descr="A:\Programas\PASTAS DO SISTEMA\claude\A--Documentos-Gest-o-de-Demandas\8ed8d158-bafd-4b35-b37c-d76ce293907f\scratchpad\vli-fonts\pptx_icons\pillar_diferencial.png">    </p:cNvPr>
+          <p:cNvPicPr>
+            <a:picLocks noChangeAspect="1"/>
+          </p:cNvPicPr>
+          <p:nvPr/>
+        </p:nvPicPr>
+        <p:blipFill>
+          <a:blip r:embed="rId2"/>
+          <a:stretch>
+            <a:fillRect/>
+          </a:stretch>
+        </p:blipFill>
+        <p:spPr>
+          <a:xfrm>
+            <a:off x="4654296" y="2157984"/>
+            <a:ext cx="256032" cy="256032"/>
+          </a:xfrm>
+          <a:prstGeom prst="rect">
+            <a:avLst/>
+          </a:prstGeom>
+        </p:spPr>
+      </p:pic>
+      <p:sp>
+        <p:nvSpPr>
+          <p:cNvPr id="13" name="Text 9"/>
           <p:cNvSpPr/>
           <p:nvPr/>
         </p:nvSpPr>
@@ -4827,7 +4947,7 @@
       </p:sp>
       <p:sp>
         <p:nvSpPr>
-          <p:cNvPr id="12" name="Text 10"/>
+          <p:cNvPr id="14" name="Text 10"/>
           <p:cNvSpPr/>
           <p:nvPr/>
         </p:nvSpPr>
@@ -4869,7 +4989,7 @@
       </p:sp>
       <p:sp>
         <p:nvSpPr>
-          <p:cNvPr id="13" name="Shape 11"/>
+          <p:cNvPr id="15" name="Shape 11"/>
           <p:cNvSpPr/>
           <p:nvPr/>
         </p:nvSpPr>
@@ -4896,7 +5016,7 @@
       </p:sp>
       <p:sp>
         <p:nvSpPr>
-          <p:cNvPr id="14" name="Shape 12"/>
+          <p:cNvPr id="16" name="Shape 12"/>
           <p:cNvSpPr/>
           <p:nvPr/>
         </p:nvSpPr>
@@ -4916,9 +5036,33 @@
           <a:ln/>
         </p:spPr>
       </p:sp>
-      <p:sp>
-        <p:nvSpPr>
-          <p:cNvPr id="15" name="Text 13"/>
+      <p:pic>
+        <p:nvPicPr>
+          <p:cNvPr id="17" name="Image 2" descr="A:\Programas\PASTAS DO SISTEMA\claude\A--Documentos-Gest-o-de-Demandas\8ed8d158-bafd-4b35-b37c-d76ce293907f\scratchpad\vli-fonts\pptx_icons\pillar_ancora.png">    </p:cNvPr>
+          <p:cNvPicPr>
+            <a:picLocks noChangeAspect="1"/>
+          </p:cNvPicPr>
+          <p:nvPr/>
+        </p:nvPicPr>
+        <p:blipFill>
+          <a:blip r:embed="rId3"/>
+          <a:stretch>
+            <a:fillRect/>
+          </a:stretch>
+        </p:blipFill>
+        <p:spPr>
+          <a:xfrm>
+            <a:off x="8430768" y="2157984"/>
+            <a:ext cx="256032" cy="256032"/>
+          </a:xfrm>
+          <a:prstGeom prst="rect">
+            <a:avLst/>
+          </a:prstGeom>
+        </p:spPr>
+      </p:pic>
+      <p:sp>
+        <p:nvSpPr>
+          <p:cNvPr id="18" name="Text 13"/>
           <p:cNvSpPr/>
           <p:nvPr/>
         </p:nvSpPr>
@@ -4957,7 +5101,7 @@
       </p:sp>
       <p:sp>
         <p:nvSpPr>
-          <p:cNvPr id="16" name="Text 14"/>
+          <p:cNvPr id="19" name="Text 14"/>
           <p:cNvSpPr/>
           <p:nvPr/>
         </p:nvSpPr>
@@ -4999,7 +5143,7 @@
       </p:sp>
       <p:sp>
         <p:nvSpPr>
-          <p:cNvPr id="17" name="Shape 15"/>
+          <p:cNvPr id="20" name="Shape 15"/>
           <p:cNvSpPr/>
           <p:nvPr/>
         </p:nvSpPr>
@@ -5021,7 +5165,7 @@
       </p:sp>
       <p:sp>
         <p:nvSpPr>
-          <p:cNvPr id="18" name="Text 16"/>
+          <p:cNvPr id="21" name="Text 16"/>
           <p:cNvSpPr/>
           <p:nvPr/>
         </p:nvSpPr>
@@ -5083,7 +5227,7 @@
       </p:sp>
       <p:sp>
         <p:nvSpPr>
-          <p:cNvPr id="19" name="Text 17"/>
+          <p:cNvPr id="22" name="Text 17"/>
           <p:cNvSpPr/>
           <p:nvPr/>
         </p:nvSpPr>
@@ -5125,7 +5269,7 @@
       </p:sp>
       <p:sp>
         <p:nvSpPr>
-          <p:cNvPr id="20" name="Text 18"/>
+          <p:cNvPr id="23" name="Text 18"/>
           <p:cNvSpPr/>
           <p:nvPr/>
         </p:nvSpPr>
@@ -5164,7 +5308,7 @@
       </p:sp>
       <p:sp>
         <p:nvSpPr>
-          <p:cNvPr id="21" name="Text 19"/>
+          <p:cNvPr id="24" name="Text 19"/>
           <p:cNvSpPr/>
           <p:nvPr/>
         </p:nvSpPr>
@@ -6111,574 +6255,40 @@
           </a:p>
         </p:txBody>
       </p:sp>
-      <p:sp>
-        <p:nvSpPr>
-          <p:cNvPr id="4" name="Shape 2"/>
-          <p:cNvSpPr/>
-          <p:nvPr/>
-        </p:nvSpPr>
-        <p:spPr>
-          <a:xfrm>
-            <a:off x="1340968" y="1691640"/>
-            <a:ext cx="2834640" cy="1737360"/>
-          </a:xfrm>
-          <a:prstGeom prst="roundRect">
-            <a:avLst>
-              <a:gd name="adj" fmla="val 5263"/>
-            </a:avLst>
-          </a:prstGeom>
-          <a:solidFill>
-            <a:srgbClr val="0F2E44"/>
-          </a:solidFill>
-          <a:ln w="12700">
-            <a:solidFill>
-              <a:srgbClr val="2C5975"/>
-            </a:solidFill>
-            <a:prstDash val="solid"/>
-          </a:ln>
-        </p:spPr>
-      </p:sp>
-      <p:sp>
-        <p:nvSpPr>
-          <p:cNvPr id="5" name="Shape 3"/>
-          <p:cNvSpPr/>
-          <p:nvPr/>
-        </p:nvSpPr>
-        <p:spPr>
-          <a:xfrm>
-            <a:off x="2392528" y="1947672"/>
-            <a:ext cx="731520" cy="731520"/>
-          </a:xfrm>
-          <a:prstGeom prst="ellipse">
-            <a:avLst/>
-          </a:prstGeom>
-          <a:solidFill>
-            <a:srgbClr val="0074C1"/>
-          </a:solidFill>
-          <a:ln/>
-        </p:spPr>
-      </p:sp>
-      <p:sp>
-        <p:nvSpPr>
-          <p:cNvPr id="6" name="Text 4"/>
-          <p:cNvSpPr/>
-          <p:nvPr/>
-        </p:nvSpPr>
-        <p:spPr>
-          <a:xfrm>
-            <a:off x="1340968" y="2743200"/>
-            <a:ext cx="2834640" cy="320040"/>
-          </a:xfrm>
-          <a:prstGeom prst="rect">
-            <a:avLst/>
-          </a:prstGeom>
-          <a:noFill/>
-          <a:ln/>
-        </p:spPr>
-        <p:txBody>
-          <a:bodyPr wrap="square" lIns="0" tIns="0" rIns="0" bIns="0" rtlCol="0" anchor="ctr"/>
-          <a:lstStyle/>
-          <a:p>
-            <a:pPr algn="ctr" indent="0" marL="0">
-              <a:buNone/>
-            </a:pPr>
-            <a:r>
-              <a:rPr lang="en-US" sz="1500" b="1" dirty="0">
-                <a:solidFill>
-                  <a:srgbClr val="FFFFFF"/>
-                </a:solidFill>
-                <a:latin typeface="Calibri" pitchFamily="34" charset="0"/>
-                <a:ea typeface="Calibri" pitchFamily="34" charset="-122"/>
-                <a:cs typeface="Calibri" pitchFamily="34" charset="-120"/>
-              </a:rPr>
-              <a:t>Percussão</a:t>
-            </a:r>
-            <a:endParaRPr lang="en-US" sz="1500" dirty="0"/>
-          </a:p>
-        </p:txBody>
-      </p:sp>
-      <p:sp>
-        <p:nvSpPr>
-          <p:cNvPr id="7" name="Text 5"/>
-          <p:cNvSpPr/>
-          <p:nvPr/>
-        </p:nvSpPr>
-        <p:spPr>
-          <a:xfrm>
-            <a:off x="1340968" y="3063240"/>
-            <a:ext cx="2834640" cy="274320"/>
-          </a:xfrm>
-          <a:prstGeom prst="rect">
-            <a:avLst/>
-          </a:prstGeom>
-          <a:noFill/>
-          <a:ln/>
-        </p:spPr>
-        <p:txBody>
-          <a:bodyPr wrap="square" lIns="0" tIns="0" rIns="0" bIns="0" rtlCol="0" anchor="ctr"/>
-          <a:lstStyle/>
-          <a:p>
-            <a:pPr algn="ctr" indent="0" marL="0">
-              <a:buNone/>
-            </a:pPr>
-            <a:r>
-              <a:rPr lang="en-US" sz="1100" dirty="0">
-                <a:solidFill>
-                  <a:srgbClr val="9AC3DE"/>
-                </a:solidFill>
-                <a:latin typeface="Calibri" pitchFamily="34" charset="0"/>
-                <a:ea typeface="Calibri" pitchFamily="34" charset="-122"/>
-                <a:cs typeface="Calibri" pitchFamily="34" charset="-120"/>
-              </a:rPr>
-              <a:t>marca o ritmo</a:t>
-            </a:r>
-            <a:endParaRPr lang="en-US" sz="1100" dirty="0"/>
-          </a:p>
-        </p:txBody>
-      </p:sp>
-      <p:sp>
-        <p:nvSpPr>
-          <p:cNvPr id="8" name="Shape 6"/>
-          <p:cNvSpPr/>
-          <p:nvPr/>
-        </p:nvSpPr>
-        <p:spPr>
-          <a:xfrm>
-            <a:off x="4678528" y="1691640"/>
-            <a:ext cx="2834640" cy="1737360"/>
-          </a:xfrm>
-          <a:prstGeom prst="roundRect">
-            <a:avLst>
-              <a:gd name="adj" fmla="val 5263"/>
-            </a:avLst>
-          </a:prstGeom>
-          <a:solidFill>
-            <a:srgbClr val="0F2E44"/>
-          </a:solidFill>
-          <a:ln w="12700">
-            <a:solidFill>
-              <a:srgbClr val="2C5975"/>
-            </a:solidFill>
-            <a:prstDash val="solid"/>
-          </a:ln>
-        </p:spPr>
-      </p:sp>
-      <p:sp>
-        <p:nvSpPr>
-          <p:cNvPr id="9" name="Shape 7"/>
-          <p:cNvSpPr/>
-          <p:nvPr/>
-        </p:nvSpPr>
-        <p:spPr>
-          <a:xfrm>
-            <a:off x="5730088" y="1947672"/>
-            <a:ext cx="731520" cy="731520"/>
-          </a:xfrm>
-          <a:prstGeom prst="ellipse">
-            <a:avLst/>
-          </a:prstGeom>
-          <a:solidFill>
-            <a:srgbClr val="EF7A1D"/>
-          </a:solidFill>
-          <a:ln/>
-        </p:spPr>
-      </p:sp>
-      <p:sp>
-        <p:nvSpPr>
-          <p:cNvPr id="10" name="Text 8"/>
-          <p:cNvSpPr/>
-          <p:nvPr/>
-        </p:nvSpPr>
-        <p:spPr>
-          <a:xfrm>
-            <a:off x="4678528" y="2743200"/>
-            <a:ext cx="2834640" cy="320040"/>
-          </a:xfrm>
-          <a:prstGeom prst="rect">
-            <a:avLst/>
-          </a:prstGeom>
-          <a:noFill/>
-          <a:ln/>
-        </p:spPr>
-        <p:txBody>
-          <a:bodyPr wrap="square" lIns="0" tIns="0" rIns="0" bIns="0" rtlCol="0" anchor="ctr"/>
-          <a:lstStyle/>
-          <a:p>
-            <a:pPr algn="ctr" indent="0" marL="0">
-              <a:buNone/>
-            </a:pPr>
-            <a:r>
-              <a:rPr lang="en-US" sz="1500" b="1" dirty="0">
-                <a:solidFill>
-                  <a:srgbClr val="FFFFFF"/>
-                </a:solidFill>
-                <a:latin typeface="Calibri" pitchFamily="34" charset="0"/>
-                <a:ea typeface="Calibri" pitchFamily="34" charset="-122"/>
-                <a:cs typeface="Calibri" pitchFamily="34" charset="-120"/>
-              </a:rPr>
-              <a:t>Sopro</a:t>
-            </a:r>
-            <a:endParaRPr lang="en-US" sz="1500" dirty="0"/>
-          </a:p>
-        </p:txBody>
-      </p:sp>
-      <p:sp>
-        <p:nvSpPr>
-          <p:cNvPr id="11" name="Text 9"/>
-          <p:cNvSpPr/>
-          <p:nvPr/>
-        </p:nvSpPr>
-        <p:spPr>
-          <a:xfrm>
-            <a:off x="4678528" y="3063240"/>
-            <a:ext cx="2834640" cy="274320"/>
-          </a:xfrm>
-          <a:prstGeom prst="rect">
-            <a:avLst/>
-          </a:prstGeom>
-          <a:noFill/>
-          <a:ln/>
-        </p:spPr>
-        <p:txBody>
-          <a:bodyPr wrap="square" lIns="0" tIns="0" rIns="0" bIns="0" rtlCol="0" anchor="ctr"/>
-          <a:lstStyle/>
-          <a:p>
-            <a:pPr algn="ctr" indent="0" marL="0">
-              <a:buNone/>
-            </a:pPr>
-            <a:r>
-              <a:rPr lang="en-US" sz="1100" dirty="0">
-                <a:solidFill>
-                  <a:srgbClr val="9AC3DE"/>
-                </a:solidFill>
-                <a:latin typeface="Calibri" pitchFamily="34" charset="0"/>
-                <a:ea typeface="Calibri" pitchFamily="34" charset="-122"/>
-                <a:cs typeface="Calibri" pitchFamily="34" charset="-120"/>
-              </a:rPr>
-              <a:t>anuncia a ação</a:t>
-            </a:r>
-            <a:endParaRPr lang="en-US" sz="1100" dirty="0"/>
-          </a:p>
-        </p:txBody>
-      </p:sp>
-      <p:sp>
-        <p:nvSpPr>
-          <p:cNvPr id="12" name="Shape 10"/>
-          <p:cNvSpPr/>
-          <p:nvPr/>
-        </p:nvSpPr>
-        <p:spPr>
-          <a:xfrm>
-            <a:off x="8016088" y="1691640"/>
-            <a:ext cx="2834640" cy="1737360"/>
-          </a:xfrm>
-          <a:prstGeom prst="roundRect">
-            <a:avLst>
-              <a:gd name="adj" fmla="val 5263"/>
-            </a:avLst>
-          </a:prstGeom>
-          <a:solidFill>
-            <a:srgbClr val="0F2E44"/>
-          </a:solidFill>
-          <a:ln w="12700">
-            <a:solidFill>
-              <a:srgbClr val="2C5975"/>
-            </a:solidFill>
-            <a:prstDash val="solid"/>
-          </a:ln>
-        </p:spPr>
-      </p:sp>
-      <p:sp>
-        <p:nvSpPr>
-          <p:cNvPr id="13" name="Shape 11"/>
-          <p:cNvSpPr/>
-          <p:nvPr/>
-        </p:nvSpPr>
-        <p:spPr>
-          <a:xfrm>
-            <a:off x="9067648" y="1947672"/>
-            <a:ext cx="731520" cy="731520"/>
-          </a:xfrm>
-          <a:prstGeom prst="ellipse">
-            <a:avLst/>
-          </a:prstGeom>
-          <a:solidFill>
-            <a:srgbClr val="0A4E7D"/>
-          </a:solidFill>
-          <a:ln/>
-        </p:spPr>
-      </p:sp>
-      <p:sp>
-        <p:nvSpPr>
-          <p:cNvPr id="14" name="Text 12"/>
-          <p:cNvSpPr/>
-          <p:nvPr/>
-        </p:nvSpPr>
-        <p:spPr>
-          <a:xfrm>
-            <a:off x="8016088" y="2743200"/>
-            <a:ext cx="2834640" cy="320040"/>
-          </a:xfrm>
-          <a:prstGeom prst="rect">
-            <a:avLst/>
-          </a:prstGeom>
-          <a:noFill/>
-          <a:ln/>
-        </p:spPr>
-        <p:txBody>
-          <a:bodyPr wrap="square" lIns="0" tIns="0" rIns="0" bIns="0" rtlCol="0" anchor="ctr"/>
-          <a:lstStyle/>
-          <a:p>
-            <a:pPr algn="ctr" indent="0" marL="0">
-              <a:buNone/>
-            </a:pPr>
-            <a:r>
-              <a:rPr lang="en-US" sz="1500" b="1" dirty="0">
-                <a:solidFill>
-                  <a:srgbClr val="FFFFFF"/>
-                </a:solidFill>
-                <a:latin typeface="Calibri" pitchFamily="34" charset="0"/>
-                <a:ea typeface="Calibri" pitchFamily="34" charset="-122"/>
-                <a:cs typeface="Calibri" pitchFamily="34" charset="-120"/>
-              </a:rPr>
-              <a:t>Puxador</a:t>
-            </a:r>
-            <a:endParaRPr lang="en-US" sz="1500" dirty="0"/>
-          </a:p>
-        </p:txBody>
-      </p:sp>
-      <p:sp>
-        <p:nvSpPr>
-          <p:cNvPr id="15" name="Text 13"/>
-          <p:cNvSpPr/>
-          <p:nvPr/>
-        </p:nvSpPr>
-        <p:spPr>
-          <a:xfrm>
-            <a:off x="8016088" y="3063240"/>
-            <a:ext cx="2834640" cy="274320"/>
-          </a:xfrm>
-          <a:prstGeom prst="rect">
-            <a:avLst/>
-          </a:prstGeom>
-          <a:noFill/>
-          <a:ln/>
-        </p:spPr>
-        <p:txBody>
-          <a:bodyPr wrap="square" lIns="0" tIns="0" rIns="0" bIns="0" rtlCol="0" anchor="ctr"/>
-          <a:lstStyle/>
-          <a:p>
-            <a:pPr algn="ctr" indent="0" marL="0">
-              <a:buNone/>
-            </a:pPr>
-            <a:r>
-              <a:rPr lang="en-US" sz="1100" dirty="0">
-                <a:solidFill>
-                  <a:srgbClr val="9AC3DE"/>
-                </a:solidFill>
-                <a:latin typeface="Calibri" pitchFamily="34" charset="0"/>
-                <a:ea typeface="Calibri" pitchFamily="34" charset="-122"/>
-                <a:cs typeface="Calibri" pitchFamily="34" charset="-120"/>
-              </a:rPr>
-              <a:t>conduz o cortejo</a:t>
-            </a:r>
-            <a:endParaRPr lang="en-US" sz="1100" dirty="0"/>
-          </a:p>
-        </p:txBody>
-      </p:sp>
-      <p:sp>
-        <p:nvSpPr>
-          <p:cNvPr id="16" name="Shape 14"/>
-          <p:cNvSpPr/>
-          <p:nvPr/>
-        </p:nvSpPr>
-        <p:spPr>
-          <a:xfrm>
-            <a:off x="1340968" y="3657600"/>
-            <a:ext cx="1417320" cy="402336"/>
-          </a:xfrm>
-          <a:prstGeom prst="roundRect">
-            <a:avLst>
-              <a:gd name="adj" fmla="val 50000"/>
-            </a:avLst>
-          </a:prstGeom>
-          <a:solidFill>
-            <a:srgbClr val="0074C1"/>
-          </a:solidFill>
-          <a:ln/>
-        </p:spPr>
-      </p:sp>
-      <p:sp>
-        <p:nvSpPr>
-          <p:cNvPr id="17" name="Text 15"/>
-          <p:cNvSpPr/>
-          <p:nvPr/>
-        </p:nvSpPr>
-        <p:spPr>
-          <a:xfrm>
-            <a:off x="1340968" y="3657600"/>
-            <a:ext cx="1417320" cy="402336"/>
-          </a:xfrm>
-          <a:prstGeom prst="rect">
-            <a:avLst/>
-          </a:prstGeom>
-          <a:noFill/>
-          <a:ln/>
-        </p:spPr>
-        <p:txBody>
-          <a:bodyPr wrap="square" lIns="0" tIns="0" rIns="0" bIns="0" rtlCol="0" anchor="ctr"/>
-          <a:lstStyle/>
-          <a:p>
-            <a:pPr algn="ctr" indent="0" marL="0">
-              <a:buNone/>
-            </a:pPr>
-            <a:r>
-              <a:rPr lang="en-US" sz="1200" b="1" dirty="0">
-                <a:solidFill>
-                  <a:srgbClr val="FFFFFF"/>
-                </a:solidFill>
-                <a:latin typeface="Calibri" pitchFamily="34" charset="0"/>
-                <a:ea typeface="Calibri" pitchFamily="34" charset="-122"/>
-                <a:cs typeface="Calibri" pitchFamily="34" charset="-120"/>
-              </a:rPr>
-              <a:t>1 · PARE</a:t>
-            </a:r>
-            <a:endParaRPr lang="en-US" sz="1200" dirty="0"/>
-          </a:p>
-        </p:txBody>
-      </p:sp>
-      <p:sp>
-        <p:nvSpPr>
-          <p:cNvPr id="18" name="Shape 16"/>
-          <p:cNvSpPr/>
-          <p:nvPr/>
-        </p:nvSpPr>
-        <p:spPr>
-          <a:xfrm>
-            <a:off x="2941168" y="3657600"/>
-            <a:ext cx="1417320" cy="402336"/>
-          </a:xfrm>
-          <a:prstGeom prst="roundRect">
-            <a:avLst>
-              <a:gd name="adj" fmla="val 50000"/>
-            </a:avLst>
-          </a:prstGeom>
-          <a:solidFill>
-            <a:srgbClr val="0074C1"/>
-          </a:solidFill>
-          <a:ln/>
-        </p:spPr>
-      </p:sp>
-      <p:sp>
-        <p:nvSpPr>
-          <p:cNvPr id="19" name="Text 17"/>
-          <p:cNvSpPr/>
-          <p:nvPr/>
-        </p:nvSpPr>
-        <p:spPr>
-          <a:xfrm>
-            <a:off x="2941168" y="3657600"/>
-            <a:ext cx="1417320" cy="402336"/>
-          </a:xfrm>
-          <a:prstGeom prst="rect">
-            <a:avLst/>
-          </a:prstGeom>
-          <a:noFill/>
-          <a:ln/>
-        </p:spPr>
-        <p:txBody>
-          <a:bodyPr wrap="square" lIns="0" tIns="0" rIns="0" bIns="0" rtlCol="0" anchor="ctr"/>
-          <a:lstStyle/>
-          <a:p>
-            <a:pPr algn="ctr" indent="0" marL="0">
-              <a:buNone/>
-            </a:pPr>
-            <a:r>
-              <a:rPr lang="en-US" sz="1200" b="1" dirty="0">
-                <a:solidFill>
-                  <a:srgbClr val="FFFFFF"/>
-                </a:solidFill>
-                <a:latin typeface="Calibri" pitchFamily="34" charset="0"/>
-                <a:ea typeface="Calibri" pitchFamily="34" charset="-122"/>
-                <a:cs typeface="Calibri" pitchFamily="34" charset="-120"/>
-              </a:rPr>
-              <a:t>2 · OLHE</a:t>
-            </a:r>
-            <a:endParaRPr lang="en-US" sz="1200" dirty="0"/>
-          </a:p>
-        </p:txBody>
-      </p:sp>
-      <p:sp>
-        <p:nvSpPr>
-          <p:cNvPr id="20" name="Shape 18"/>
-          <p:cNvSpPr/>
-          <p:nvPr/>
-        </p:nvSpPr>
-        <p:spPr>
-          <a:xfrm>
-            <a:off x="4541368" y="3657600"/>
-            <a:ext cx="1417320" cy="402336"/>
-          </a:xfrm>
-          <a:prstGeom prst="roundRect">
-            <a:avLst>
-              <a:gd name="adj" fmla="val 50000"/>
-            </a:avLst>
-          </a:prstGeom>
-          <a:solidFill>
-            <a:srgbClr val="EF7A1D"/>
-          </a:solidFill>
-          <a:ln/>
-        </p:spPr>
-      </p:sp>
-      <p:sp>
-        <p:nvSpPr>
-          <p:cNvPr id="21" name="Text 19"/>
-          <p:cNvSpPr/>
-          <p:nvPr/>
-        </p:nvSpPr>
-        <p:spPr>
-          <a:xfrm>
-            <a:off x="4541368" y="3657600"/>
-            <a:ext cx="1417320" cy="402336"/>
-          </a:xfrm>
-          <a:prstGeom prst="rect">
-            <a:avLst/>
-          </a:prstGeom>
-          <a:noFill/>
-          <a:ln/>
-        </p:spPr>
-        <p:txBody>
-          <a:bodyPr wrap="square" lIns="0" tIns="0" rIns="0" bIns="0" rtlCol="0" anchor="ctr"/>
-          <a:lstStyle/>
-          <a:p>
-            <a:pPr algn="ctr" indent="0" marL="0">
-              <a:buNone/>
-            </a:pPr>
-            <a:r>
-              <a:rPr lang="en-US" sz="1200" b="1" dirty="0">
-                <a:solidFill>
-                  <a:srgbClr val="FFFFFF"/>
-                </a:solidFill>
-                <a:latin typeface="Calibri" pitchFamily="34" charset="0"/>
-                <a:ea typeface="Calibri" pitchFamily="34" charset="-122"/>
-                <a:cs typeface="Calibri" pitchFamily="34" charset="-120"/>
-              </a:rPr>
-              <a:t>3 · ESCUTE</a:t>
-            </a:r>
-            <a:endParaRPr lang="en-US" sz="1200" dirty="0"/>
-          </a:p>
-        </p:txBody>
-      </p:sp>
-      <p:sp>
-        <p:nvSpPr>
-          <p:cNvPr id="22" name="Text 20"/>
-          <p:cNvSpPr/>
-          <p:nvPr/>
-        </p:nvSpPr>
-        <p:spPr>
-          <a:xfrm>
-            <a:off x="502920" y="4343400"/>
-            <a:ext cx="5212080" cy="1005840"/>
+      <p:pic>
+        <p:nvPicPr>
+          <p:cNvPr id="4" name="Image 0" descr="A:\Programas\PASTAS DO SISTEMA\claude\A--Documentos-Gest-o-de-Demandas\8ed8d158-bafd-4b35-b37c-d76ce293907f\scratchpad\vli-fonts\pptx_icons\scene4.png">    </p:cNvPr>
+          <p:cNvPicPr>
+            <a:picLocks noChangeAspect="1"/>
+          </p:cNvPicPr>
+          <p:nvPr/>
+        </p:nvPicPr>
+        <p:blipFill>
+          <a:blip r:embed="rId1"/>
+          <a:stretch>
+            <a:fillRect/>
+          </a:stretch>
+        </p:blipFill>
+        <p:spPr>
+          <a:xfrm>
+            <a:off x="792328" y="1325880"/>
+            <a:ext cx="10607040" cy="3480435"/>
+          </a:xfrm>
+          <a:prstGeom prst="rect">
+            <a:avLst/>
+          </a:prstGeom>
+        </p:spPr>
+      </p:pic>
+      <p:sp>
+        <p:nvSpPr>
+          <p:cNvPr id="5" name="Text 2"/>
+          <p:cNvSpPr/>
+          <p:nvPr/>
+        </p:nvSpPr>
+        <p:spPr>
+          <a:xfrm>
+            <a:off x="502920" y="4916043"/>
+            <a:ext cx="5212080" cy="822960"/>
           </a:xfrm>
           <a:prstGeom prst="rect">
             <a:avLst/>
@@ -6692,12 +6302,12 @@
           <a:p>
             <a:pPr indent="0" marL="0">
               <a:lnSpc>
-                <a:spcPts val="1800"/>
+                <a:spcPts val="1600"/>
               </a:lnSpc>
               <a:buNone/>
             </a:pPr>
             <a:r>
-              <a:rPr lang="en-US" sz="1250" dirty="0">
+              <a:rPr lang="en-US" sz="1150" dirty="0">
                 <a:solidFill>
                   <a:srgbClr val="C8DEEC"/>
                 </a:solidFill>
@@ -6707,20 +6317,20 @@
               </a:rPr>
               <a:t>Intervenção cênica itinerante: três atores caracterizados interagem com o público de forma lúdica, percorrendo o território e reforçando as três regras de ouro da segurança ferroviária.</a:t>
             </a:r>
-            <a:endParaRPr lang="en-US" sz="1250" dirty="0"/>
-          </a:p>
-        </p:txBody>
-      </p:sp>
-      <p:sp>
-        <p:nvSpPr>
-          <p:cNvPr id="23" name="Shape 21"/>
-          <p:cNvSpPr/>
-          <p:nvPr/>
-        </p:nvSpPr>
-        <p:spPr>
-          <a:xfrm>
-            <a:off x="6035040" y="4343400"/>
-            <a:ext cx="0" cy="1005840"/>
+            <a:endParaRPr lang="en-US" sz="1150" dirty="0"/>
+          </a:p>
+        </p:txBody>
+      </p:sp>
+      <p:sp>
+        <p:nvSpPr>
+          <p:cNvPr id="6" name="Shape 3"/>
+          <p:cNvSpPr/>
+          <p:nvPr/>
+        </p:nvSpPr>
+        <p:spPr>
+          <a:xfrm>
+            <a:off x="6035040" y="4916043"/>
+            <a:ext cx="0" cy="822960"/>
           </a:xfrm>
           <a:prstGeom prst="line">
             <a:avLst/>
@@ -6736,14 +6346,14 @@
       </p:sp>
       <p:sp>
         <p:nvSpPr>
-          <p:cNvPr id="24" name="Text 22"/>
-          <p:cNvSpPr/>
-          <p:nvPr/>
-        </p:nvSpPr>
-        <p:spPr>
-          <a:xfrm>
-            <a:off x="6217920" y="4343400"/>
-            <a:ext cx="5394960" cy="1005840"/>
+          <p:cNvPr id="7" name="Text 4"/>
+          <p:cNvSpPr/>
+          <p:nvPr/>
+        </p:nvSpPr>
+        <p:spPr>
+          <a:xfrm>
+            <a:off x="6217920" y="4916043"/>
+            <a:ext cx="5394960" cy="822960"/>
           </a:xfrm>
           <a:prstGeom prst="rect">
             <a:avLst/>
@@ -6757,12 +6367,12 @@
           <a:p>
             <a:pPr indent="0" marL="0">
               <a:lnSpc>
-                <a:spcPts val="1800"/>
+                <a:spcPts val="1600"/>
               </a:lnSpc>
               <a:buNone/>
             </a:pPr>
             <a:r>
-              <a:rPr lang="en-US" sz="1250" i="1" dirty="0">
+              <a:rPr lang="en-US" sz="1150" i="1" dirty="0">
                 <a:solidFill>
                   <a:srgbClr val="FFFFFF"/>
                 </a:solidFill>
@@ -6772,13 +6382,13 @@
               </a:rPr>
               <a:t>"Todas as ações envolvem cultura, teatro, arte." — coordenação do Segurança nos Trilhos. Formato único entre as concessionárias do movimento.</a:t>
             </a:r>
-            <a:endParaRPr lang="en-US" sz="1250" dirty="0"/>
-          </a:p>
-        </p:txBody>
-      </p:sp>
-      <p:sp>
-        <p:nvSpPr>
-          <p:cNvPr id="25" name="Text 23"/>
+            <a:endParaRPr lang="en-US" sz="1150" dirty="0"/>
+          </a:p>
+        </p:txBody>
+      </p:sp>
+      <p:sp>
+        <p:nvSpPr>
+          <p:cNvPr id="8" name="Text 5"/>
           <p:cNvSpPr/>
           <p:nvPr/>
         </p:nvSpPr>
@@ -6817,7 +6427,7 @@
       </p:sp>
       <p:sp>
         <p:nvSpPr>
-          <p:cNvPr id="26" name="Text 24"/>
+          <p:cNvPr id="9" name="Text 6"/>
           <p:cNvSpPr/>
           <p:nvPr/>
         </p:nvSpPr>
@@ -7012,9 +6622,33 @@
           <a:ln/>
         </p:spPr>
       </p:sp>
-      <p:sp>
-        <p:nvSpPr>
-          <p:cNvPr id="6" name="Shape 4"/>
+      <p:pic>
+        <p:nvPicPr>
+          <p:cNvPr id="6" name="Image 0" descr="A:\Programas\PASTAS DO SISTEMA\claude\A--Documentos-Gest-o-de-Demandas\8ed8d158-bafd-4b35-b37c-d76ce293907f\scratchpad\vli-fonts\pptx_icons\fmt_blitz.png">    </p:cNvPr>
+          <p:cNvPicPr>
+            <a:picLocks noChangeAspect="1"/>
+          </p:cNvPicPr>
+          <p:nvPr/>
+        </p:nvPicPr>
+        <p:blipFill>
+          <a:blip r:embed="rId1"/>
+          <a:stretch>
+            <a:fillRect/>
+          </a:stretch>
+        </p:blipFill>
+        <p:spPr>
+          <a:xfrm>
+            <a:off x="2007108" y="1920240"/>
+            <a:ext cx="512064" cy="512064"/>
+          </a:xfrm>
+          <a:prstGeom prst="rect">
+            <a:avLst/>
+          </a:prstGeom>
+        </p:spPr>
+      </p:pic>
+      <p:sp>
+        <p:nvSpPr>
+          <p:cNvPr id="7" name="Shape 4"/>
           <p:cNvSpPr/>
           <p:nvPr/>
         </p:nvSpPr>
@@ -7039,7 +6673,7 @@
       </p:sp>
       <p:sp>
         <p:nvSpPr>
-          <p:cNvPr id="7" name="Text 5"/>
+          <p:cNvPr id="8" name="Text 5"/>
           <p:cNvSpPr/>
           <p:nvPr/>
         </p:nvSpPr>
@@ -7078,7 +6712,7 @@
       </p:sp>
       <p:sp>
         <p:nvSpPr>
-          <p:cNvPr id="8" name="Text 6"/>
+          <p:cNvPr id="9" name="Text 6"/>
           <p:cNvSpPr/>
           <p:nvPr/>
         </p:nvSpPr>
@@ -7120,7 +6754,7 @@
       </p:sp>
       <p:sp>
         <p:nvSpPr>
-          <p:cNvPr id="9" name="Text 7"/>
+          <p:cNvPr id="10" name="Text 7"/>
           <p:cNvSpPr/>
           <p:nvPr/>
         </p:nvSpPr>
@@ -7159,7 +6793,7 @@
       </p:sp>
       <p:sp>
         <p:nvSpPr>
-          <p:cNvPr id="10" name="Shape 8"/>
+          <p:cNvPr id="11" name="Shape 8"/>
           <p:cNvSpPr/>
           <p:nvPr/>
         </p:nvSpPr>
@@ -7179,9 +6813,33 @@
           <a:ln/>
         </p:spPr>
       </p:sp>
-      <p:sp>
-        <p:nvSpPr>
-          <p:cNvPr id="11" name="Shape 9"/>
+      <p:pic>
+        <p:nvPicPr>
+          <p:cNvPr id="12" name="Image 1" descr="A:\Programas\PASTAS DO SISTEMA\claude\A--Documentos-Gest-o-de-Demandas\8ed8d158-bafd-4b35-b37c-d76ce293907f\scratchpad\vli-fonts\pptx_icons\fmt_pista.png">    </p:cNvPr>
+          <p:cNvPicPr>
+            <a:picLocks noChangeAspect="1"/>
+          </p:cNvPicPr>
+          <p:nvPr/>
+        </p:nvPicPr>
+        <p:blipFill>
+          <a:blip r:embed="rId2"/>
+          <a:stretch>
+            <a:fillRect/>
+          </a:stretch>
+        </p:blipFill>
+        <p:spPr>
+          <a:xfrm>
+            <a:off x="5783580" y="1920240"/>
+            <a:ext cx="512064" cy="512064"/>
+          </a:xfrm>
+          <a:prstGeom prst="rect">
+            <a:avLst/>
+          </a:prstGeom>
+        </p:spPr>
+      </p:pic>
+      <p:sp>
+        <p:nvSpPr>
+          <p:cNvPr id="13" name="Shape 9"/>
           <p:cNvSpPr/>
           <p:nvPr/>
         </p:nvSpPr>
@@ -7206,7 +6864,7 @@
       </p:sp>
       <p:sp>
         <p:nvSpPr>
-          <p:cNvPr id="12" name="Text 10"/>
+          <p:cNvPr id="14" name="Text 10"/>
           <p:cNvSpPr/>
           <p:nvPr/>
         </p:nvSpPr>
@@ -7245,7 +6903,7 @@
       </p:sp>
       <p:sp>
         <p:nvSpPr>
-          <p:cNvPr id="13" name="Text 11"/>
+          <p:cNvPr id="15" name="Text 11"/>
           <p:cNvSpPr/>
           <p:nvPr/>
         </p:nvSpPr>
@@ -7287,7 +6945,7 @@
       </p:sp>
       <p:sp>
         <p:nvSpPr>
-          <p:cNvPr id="14" name="Text 12"/>
+          <p:cNvPr id="16" name="Text 12"/>
           <p:cNvSpPr/>
           <p:nvPr/>
         </p:nvSpPr>
@@ -7326,7 +6984,7 @@
       </p:sp>
       <p:sp>
         <p:nvSpPr>
-          <p:cNvPr id="15" name="Shape 13"/>
+          <p:cNvPr id="17" name="Shape 13"/>
           <p:cNvSpPr/>
           <p:nvPr/>
         </p:nvSpPr>
@@ -7346,9 +7004,33 @@
           <a:ln/>
         </p:spPr>
       </p:sp>
-      <p:sp>
-        <p:nvSpPr>
-          <p:cNvPr id="16" name="Shape 14"/>
+      <p:pic>
+        <p:nvPicPr>
+          <p:cNvPr id="18" name="Image 2" descr="A:\Programas\PASTAS DO SISTEMA\claude\A--Documentos-Gest-o-de-Demandas\8ed8d158-bafd-4b35-b37c-d76ce293907f\scratchpad\vli-fonts\pptx_icons\fmt_comunidade.png">    </p:cNvPr>
+          <p:cNvPicPr>
+            <a:picLocks noChangeAspect="1"/>
+          </p:cNvPicPr>
+          <p:nvPr/>
+        </p:nvPicPr>
+        <p:blipFill>
+          <a:blip r:embed="rId3"/>
+          <a:stretch>
+            <a:fillRect/>
+          </a:stretch>
+        </p:blipFill>
+        <p:spPr>
+          <a:xfrm>
+            <a:off x="9560052" y="1920240"/>
+            <a:ext cx="512064" cy="512064"/>
+          </a:xfrm>
+          <a:prstGeom prst="rect">
+            <a:avLst/>
+          </a:prstGeom>
+        </p:spPr>
+      </p:pic>
+      <p:sp>
+        <p:nvSpPr>
+          <p:cNvPr id="19" name="Shape 14"/>
           <p:cNvSpPr/>
           <p:nvPr/>
         </p:nvSpPr>
@@ -7373,7 +7055,7 @@
       </p:sp>
       <p:sp>
         <p:nvSpPr>
-          <p:cNvPr id="17" name="Text 15"/>
+          <p:cNvPr id="20" name="Text 15"/>
           <p:cNvSpPr/>
           <p:nvPr/>
         </p:nvSpPr>
@@ -7412,7 +7094,7 @@
       </p:sp>
       <p:sp>
         <p:nvSpPr>
-          <p:cNvPr id="18" name="Text 16"/>
+          <p:cNvPr id="21" name="Text 16"/>
           <p:cNvSpPr/>
           <p:nvPr/>
         </p:nvSpPr>
@@ -7454,7 +7136,7 @@
       </p:sp>
       <p:sp>
         <p:nvSpPr>
-          <p:cNvPr id="19" name="Text 17"/>
+          <p:cNvPr id="22" name="Text 17"/>
           <p:cNvSpPr/>
           <p:nvPr/>
         </p:nvSpPr>
@@ -7493,7 +7175,7 @@
       </p:sp>
       <p:sp>
         <p:nvSpPr>
-          <p:cNvPr id="20" name="Shape 18"/>
+          <p:cNvPr id="23" name="Shape 18"/>
           <p:cNvSpPr/>
           <p:nvPr/>
         </p:nvSpPr>
@@ -7515,7 +7197,7 @@
       </p:sp>
       <p:sp>
         <p:nvSpPr>
-          <p:cNvPr id="21" name="Text 19"/>
+          <p:cNvPr id="24" name="Text 19"/>
           <p:cNvSpPr/>
           <p:nvPr/>
         </p:nvSpPr>
@@ -7554,7 +7236,7 @@
       </p:sp>
       <p:sp>
         <p:nvSpPr>
-          <p:cNvPr id="22" name="Text 20"/>
+          <p:cNvPr id="25" name="Text 20"/>
           <p:cNvSpPr/>
           <p:nvPr/>
         </p:nvSpPr>
@@ -7596,7 +7278,7 @@
       </p:sp>
       <p:sp>
         <p:nvSpPr>
-          <p:cNvPr id="23" name="Text 21"/>
+          <p:cNvPr id="26" name="Text 21"/>
           <p:cNvSpPr/>
           <p:nvPr/>
         </p:nvSpPr>
@@ -7635,7 +7317,7 @@
       </p:sp>
       <p:sp>
         <p:nvSpPr>
-          <p:cNvPr id="24" name="Text 22"/>
+          <p:cNvPr id="27" name="Text 22"/>
           <p:cNvSpPr/>
           <p:nvPr/>
         </p:nvSpPr>
@@ -9079,9 +8761,33 @@
           <a:ln/>
         </p:spPr>
       </p:sp>
-      <p:sp>
-        <p:nvSpPr>
-          <p:cNvPr id="7" name="Text 5"/>
+      <p:pic>
+        <p:nvPicPr>
+          <p:cNvPr id="7" name="Image 0" descr="A:\Programas\PASTAS DO SISTEMA\claude\A--Documentos-Gest-o-de-Demandas\8ed8d158-bafd-4b35-b37c-d76ce293907f\scratchpad\vli-fonts\pptx_icons\betim_simulado.png">    </p:cNvPr>
+          <p:cNvPicPr>
+            <a:picLocks noChangeAspect="1"/>
+          </p:cNvPicPr>
+          <p:nvPr/>
+        </p:nvPicPr>
+        <p:blipFill>
+          <a:blip r:embed="rId1"/>
+          <a:stretch>
+            <a:fillRect/>
+          </a:stretch>
+        </p:blipFill>
+        <p:spPr>
+          <a:xfrm>
+            <a:off x="859536" y="2029968"/>
+            <a:ext cx="338328" cy="338328"/>
+          </a:xfrm>
+          <a:prstGeom prst="rect">
+            <a:avLst/>
+          </a:prstGeom>
+        </p:spPr>
+      </p:pic>
+      <p:sp>
+        <p:nvSpPr>
+          <p:cNvPr id="8" name="Text 5"/>
           <p:cNvSpPr/>
           <p:nvPr/>
         </p:nvSpPr>
@@ -9120,7 +8826,7 @@
       </p:sp>
       <p:sp>
         <p:nvSpPr>
-          <p:cNvPr id="8" name="Text 6"/>
+          <p:cNvPr id="9" name="Text 6"/>
           <p:cNvSpPr/>
           <p:nvPr/>
         </p:nvSpPr>
@@ -9159,7 +8865,7 @@
       </p:sp>
       <p:sp>
         <p:nvSpPr>
-          <p:cNvPr id="9" name="Shape 7"/>
+          <p:cNvPr id="10" name="Shape 7"/>
           <p:cNvSpPr/>
           <p:nvPr/>
         </p:nvSpPr>
@@ -9186,7 +8892,7 @@
       </p:sp>
       <p:sp>
         <p:nvSpPr>
-          <p:cNvPr id="10" name="Shape 8"/>
+          <p:cNvPr id="11" name="Shape 8"/>
           <p:cNvSpPr/>
           <p:nvPr/>
         </p:nvSpPr>
@@ -9206,9 +8912,33 @@
           <a:ln/>
         </p:spPr>
       </p:sp>
-      <p:sp>
-        <p:nvSpPr>
-          <p:cNvPr id="11" name="Text 9"/>
+      <p:pic>
+        <p:nvPicPr>
+          <p:cNvPr id="12" name="Image 1" descr="A:\Programas\PASTAS DO SISTEMA\claude\A--Documentos-Gest-o-de-Demandas\8ed8d158-bafd-4b35-b37c-d76ce293907f\scratchpad\vli-fonts\pptx_icons\betim_cortejo.png">    </p:cNvPr>
+          <p:cNvPicPr>
+            <a:picLocks noChangeAspect="1"/>
+          </p:cNvPicPr>
+          <p:nvPr/>
+        </p:nvPicPr>
+        <p:blipFill>
+          <a:blip r:embed="rId2"/>
+          <a:stretch>
+            <a:fillRect/>
+          </a:stretch>
+        </p:blipFill>
+        <p:spPr>
+          <a:xfrm>
+            <a:off x="1408176" y="3172968"/>
+            <a:ext cx="338328" cy="338328"/>
+          </a:xfrm>
+          <a:prstGeom prst="rect">
+            <a:avLst/>
+          </a:prstGeom>
+        </p:spPr>
+      </p:pic>
+      <p:sp>
+        <p:nvSpPr>
+          <p:cNvPr id="13" name="Text 9"/>
           <p:cNvSpPr/>
           <p:nvPr/>
         </p:nvSpPr>
@@ -9247,7 +8977,7 @@
       </p:sp>
       <p:sp>
         <p:nvSpPr>
-          <p:cNvPr id="12" name="Text 10"/>
+          <p:cNvPr id="14" name="Text 10"/>
           <p:cNvSpPr/>
           <p:nvPr/>
         </p:nvSpPr>
@@ -9286,7 +9016,7 @@
       </p:sp>
       <p:sp>
         <p:nvSpPr>
-          <p:cNvPr id="13" name="Shape 11"/>
+          <p:cNvPr id="15" name="Shape 11"/>
           <p:cNvSpPr/>
           <p:nvPr/>
         </p:nvSpPr>
@@ -9311,7 +9041,7 @@
       </p:sp>
       <p:sp>
         <p:nvSpPr>
-          <p:cNvPr id="14" name="Text 12"/>
+          <p:cNvPr id="16" name="Text 12"/>
           <p:cNvSpPr/>
           <p:nvPr/>
         </p:nvSpPr>
@@ -9350,7 +9080,7 @@
       </p:sp>
       <p:sp>
         <p:nvSpPr>
-          <p:cNvPr id="15" name="Text 13"/>
+          <p:cNvPr id="17" name="Text 13"/>
           <p:cNvSpPr/>
           <p:nvPr/>
         </p:nvSpPr>
@@ -9389,7 +9119,7 @@
       </p:sp>
       <p:sp>
         <p:nvSpPr>
-          <p:cNvPr id="16" name="Text 14"/>
+          <p:cNvPr id="18" name="Text 14"/>
           <p:cNvSpPr/>
           <p:nvPr/>
         </p:nvSpPr>
@@ -9431,7 +9161,7 @@
       </p:sp>
       <p:sp>
         <p:nvSpPr>
-          <p:cNvPr id="17" name="Shape 15"/>
+          <p:cNvPr id="19" name="Shape 15"/>
           <p:cNvSpPr/>
           <p:nvPr/>
         </p:nvSpPr>
@@ -9455,7 +9185,7 @@
       </p:sp>
       <p:sp>
         <p:nvSpPr>
-          <p:cNvPr id="18" name="Shape 16"/>
+          <p:cNvPr id="20" name="Shape 16"/>
           <p:cNvSpPr/>
           <p:nvPr/>
         </p:nvSpPr>
@@ -9478,7 +9208,7 @@
       </p:sp>
       <p:sp>
         <p:nvSpPr>
-          <p:cNvPr id="19" name="Text 17"/>
+          <p:cNvPr id="21" name="Text 17"/>
           <p:cNvSpPr/>
           <p:nvPr/>
         </p:nvSpPr>
@@ -9520,7 +9250,7 @@
       </p:sp>
       <p:sp>
         <p:nvSpPr>
-          <p:cNvPr id="20" name="Shape 18"/>
+          <p:cNvPr id="22" name="Shape 18"/>
           <p:cNvSpPr/>
           <p:nvPr/>
         </p:nvSpPr>
@@ -9551,7 +9281,7 @@
       </p:sp>
       <p:sp>
         <p:nvSpPr>
-          <p:cNvPr id="21" name="Text 19"/>
+          <p:cNvPr id="23" name="Text 19"/>
           <p:cNvSpPr/>
           <p:nvPr/>
         </p:nvSpPr>
@@ -9590,7 +9320,7 @@
       </p:sp>
       <p:sp>
         <p:nvSpPr>
-          <p:cNvPr id="22" name="Text 20"/>
+          <p:cNvPr id="24" name="Text 20"/>
           <p:cNvSpPr/>
           <p:nvPr/>
         </p:nvSpPr>
@@ -9632,7 +9362,7 @@
       </p:sp>
       <p:sp>
         <p:nvSpPr>
-          <p:cNvPr id="23" name="Shape 21"/>
+          <p:cNvPr id="25" name="Shape 21"/>
           <p:cNvSpPr/>
           <p:nvPr/>
         </p:nvSpPr>
@@ -9663,7 +9393,7 @@
       </p:sp>
       <p:sp>
         <p:nvSpPr>
-          <p:cNvPr id="24" name="Text 22"/>
+          <p:cNvPr id="26" name="Text 22"/>
           <p:cNvSpPr/>
           <p:nvPr/>
         </p:nvSpPr>
@@ -9702,7 +9432,7 @@
       </p:sp>
       <p:sp>
         <p:nvSpPr>
-          <p:cNvPr id="25" name="Text 23"/>
+          <p:cNvPr id="27" name="Text 23"/>
           <p:cNvSpPr/>
           <p:nvPr/>
         </p:nvSpPr>
@@ -9744,7 +9474,7 @@
       </p:sp>
       <p:sp>
         <p:nvSpPr>
-          <p:cNvPr id="26" name="Shape 24"/>
+          <p:cNvPr id="28" name="Shape 24"/>
           <p:cNvSpPr/>
           <p:nvPr/>
         </p:nvSpPr>
@@ -9775,7 +9505,7 @@
       </p:sp>
       <p:sp>
         <p:nvSpPr>
-          <p:cNvPr id="27" name="Text 25"/>
+          <p:cNvPr id="29" name="Text 25"/>
           <p:cNvSpPr/>
           <p:nvPr/>
         </p:nvSpPr>
@@ -9814,7 +9544,7 @@
       </p:sp>
       <p:sp>
         <p:nvSpPr>
-          <p:cNvPr id="28" name="Text 26"/>
+          <p:cNvPr id="30" name="Text 26"/>
           <p:cNvSpPr/>
           <p:nvPr/>
         </p:nvSpPr>
@@ -9856,7 +9586,7 @@
       </p:sp>
       <p:sp>
         <p:nvSpPr>
-          <p:cNvPr id="29" name="Text 27"/>
+          <p:cNvPr id="31" name="Text 27"/>
           <p:cNvSpPr/>
           <p:nvPr/>
         </p:nvSpPr>
@@ -9895,7 +9625,7 @@
       </p:sp>
       <p:sp>
         <p:nvSpPr>
-          <p:cNvPr id="30" name="Text 28"/>
+          <p:cNvPr id="32" name="Text 28"/>
           <p:cNvSpPr/>
           <p:nvPr/>
         </p:nvSpPr>
@@ -10373,32 +10103,56 @@
           </a:ln>
         </p:spPr>
       </p:sp>
-      <p:sp>
-        <p:nvSpPr>
-          <p:cNvPr id="14" name="Text 12"/>
-          <p:cNvSpPr/>
-          <p:nvPr/>
-        </p:nvSpPr>
-        <p:spPr>
-          <a:xfrm>
-            <a:off x="4160520" y="2139696"/>
-            <a:ext cx="1536192" cy="274320"/>
-          </a:xfrm>
-          <a:prstGeom prst="rect">
-            <a:avLst/>
-          </a:prstGeom>
-          <a:noFill/>
-          <a:ln/>
-        </p:spPr>
-        <p:txBody>
-          <a:bodyPr wrap="square" lIns="0" tIns="0" rIns="0" bIns="0" rtlCol="0" anchor="ctr"/>
-          <a:lstStyle/>
-          <a:p>
-            <a:pPr indent="0" marL="0">
-              <a:buNone/>
-            </a:pPr>
-            <a:r>
-              <a:rPr lang="en-US" sz="1050" b="1" dirty="0">
+      <p:pic>
+        <p:nvPicPr>
+          <p:cNvPr id="14" name="Image 0" descr="A:\Programas\PASTAS DO SISTEMA\claude\A--Documentos-Gest-o-de-Demandas\8ed8d158-bafd-4b35-b37c-d76ce293907f\scratchpad\vli-fonts\pptx_icons\mat_banner.png">    </p:cNvPr>
+          <p:cNvPicPr>
+            <a:picLocks noChangeAspect="1"/>
+          </p:cNvPicPr>
+          <p:nvPr/>
+        </p:nvPicPr>
+        <p:blipFill>
+          <a:blip r:embed="rId1"/>
+          <a:stretch>
+            <a:fillRect/>
+          </a:stretch>
+        </p:blipFill>
+        <p:spPr>
+          <a:xfrm>
+            <a:off x="4160520" y="2121408"/>
+            <a:ext cx="201168" cy="201168"/>
+          </a:xfrm>
+          <a:prstGeom prst="rect">
+            <a:avLst/>
+          </a:prstGeom>
+        </p:spPr>
+      </p:pic>
+      <p:sp>
+        <p:nvSpPr>
+          <p:cNvPr id="15" name="Text 12"/>
+          <p:cNvSpPr/>
+          <p:nvPr/>
+        </p:nvSpPr>
+        <p:spPr>
+          <a:xfrm>
+            <a:off x="4160520" y="2359152"/>
+            <a:ext cx="1536192" cy="256032"/>
+          </a:xfrm>
+          <a:prstGeom prst="rect">
+            <a:avLst/>
+          </a:prstGeom>
+          <a:noFill/>
+          <a:ln/>
+        </p:spPr>
+        <p:txBody>
+          <a:bodyPr wrap="square" lIns="0" tIns="0" rIns="0" bIns="0" rtlCol="0" anchor="ctr"/>
+          <a:lstStyle/>
+          <a:p>
+            <a:pPr indent="0" marL="0">
+              <a:buNone/>
+            </a:pPr>
+            <a:r>
+              <a:rPr lang="en-US" sz="1000" b="1" dirty="0">
                 <a:solidFill>
                   <a:srgbClr val="1C2933"/>
                 </a:solidFill>
@@ -10408,20 +10162,20 @@
               </a:rPr>
               <a:t>Banner / faixa</a:t>
             </a:r>
-            <a:endParaRPr lang="en-US" sz="1050" dirty="0"/>
-          </a:p>
-        </p:txBody>
-      </p:sp>
-      <p:sp>
-        <p:nvSpPr>
-          <p:cNvPr id="15" name="Text 13"/>
-          <p:cNvSpPr/>
-          <p:nvPr/>
-        </p:nvSpPr>
-        <p:spPr>
-          <a:xfrm>
-            <a:off x="4160520" y="2414016"/>
-            <a:ext cx="1536192" cy="384048"/>
+            <a:endParaRPr lang="en-US" sz="1000" dirty="0"/>
+          </a:p>
+        </p:txBody>
+      </p:sp>
+      <p:sp>
+        <p:nvSpPr>
+          <p:cNvPr id="16" name="Text 13"/>
+          <p:cNvSpPr/>
+          <p:nvPr/>
+        </p:nvSpPr>
+        <p:spPr>
+          <a:xfrm>
+            <a:off x="4160520" y="2596896"/>
+            <a:ext cx="1536192" cy="237744"/>
           </a:xfrm>
           <a:prstGeom prst="rect">
             <a:avLst/>
@@ -10435,12 +10189,12 @@
           <a:p>
             <a:pPr indent="0" marL="0">
               <a:lnSpc>
-                <a:spcPts val="1100"/>
+                <a:spcPts val="1000"/>
               </a:lnSpc>
               <a:buNone/>
             </a:pPr>
             <a:r>
-              <a:rPr lang="en-US" sz="870" dirty="0">
+              <a:rPr lang="en-US" sz="830" dirty="0">
                 <a:solidFill>
                   <a:srgbClr val="5E6E77"/>
                 </a:solidFill>
@@ -10450,13 +10204,13 @@
               </a:rPr>
               <a:t>Para o local da ação-âncora</a:t>
             </a:r>
-            <a:endParaRPr lang="en-US" sz="870" dirty="0"/>
-          </a:p>
-        </p:txBody>
-      </p:sp>
-      <p:sp>
-        <p:nvSpPr>
-          <p:cNvPr id="16" name="Shape 14"/>
+            <a:endParaRPr lang="en-US" sz="830" dirty="0"/>
+          </a:p>
+        </p:txBody>
+      </p:sp>
+      <p:sp>
+        <p:nvSpPr>
+          <p:cNvPr id="17" name="Shape 14"/>
           <p:cNvSpPr/>
           <p:nvPr/>
         </p:nvSpPr>
@@ -10481,32 +10235,56 @@
           </a:ln>
         </p:spPr>
       </p:sp>
-      <p:sp>
-        <p:nvSpPr>
-          <p:cNvPr id="17" name="Text 15"/>
-          <p:cNvSpPr/>
-          <p:nvPr/>
-        </p:nvSpPr>
-        <p:spPr>
-          <a:xfrm>
-            <a:off x="6099048" y="2139696"/>
-            <a:ext cx="1536192" cy="274320"/>
-          </a:xfrm>
-          <a:prstGeom prst="rect">
-            <a:avLst/>
-          </a:prstGeom>
-          <a:noFill/>
-          <a:ln/>
-        </p:spPr>
-        <p:txBody>
-          <a:bodyPr wrap="square" lIns="0" tIns="0" rIns="0" bIns="0" rtlCol="0" anchor="ctr"/>
-          <a:lstStyle/>
-          <a:p>
-            <a:pPr indent="0" marL="0">
-              <a:buNone/>
-            </a:pPr>
-            <a:r>
-              <a:rPr lang="en-US" sz="1050" b="1" dirty="0">
+      <p:pic>
+        <p:nvPicPr>
+          <p:cNvPr id="18" name="Image 1" descr="A:\Programas\PASTAS DO SISTEMA\claude\A--Documentos-Gest-o-de-Demandas\8ed8d158-bafd-4b35-b37c-d76ce293907f\scratchpad\vli-fonts\pptx_icons\mat_placa.png">    </p:cNvPr>
+          <p:cNvPicPr>
+            <a:picLocks noChangeAspect="1"/>
+          </p:cNvPicPr>
+          <p:nvPr/>
+        </p:nvPicPr>
+        <p:blipFill>
+          <a:blip r:embed="rId2"/>
+          <a:stretch>
+            <a:fillRect/>
+          </a:stretch>
+        </p:blipFill>
+        <p:spPr>
+          <a:xfrm>
+            <a:off x="6099048" y="2121408"/>
+            <a:ext cx="201168" cy="201168"/>
+          </a:xfrm>
+          <a:prstGeom prst="rect">
+            <a:avLst/>
+          </a:prstGeom>
+        </p:spPr>
+      </p:pic>
+      <p:sp>
+        <p:nvSpPr>
+          <p:cNvPr id="19" name="Text 15"/>
+          <p:cNvSpPr/>
+          <p:nvPr/>
+        </p:nvSpPr>
+        <p:spPr>
+          <a:xfrm>
+            <a:off x="6099048" y="2359152"/>
+            <a:ext cx="1536192" cy="256032"/>
+          </a:xfrm>
+          <a:prstGeom prst="rect">
+            <a:avLst/>
+          </a:prstGeom>
+          <a:noFill/>
+          <a:ln/>
+        </p:spPr>
+        <p:txBody>
+          <a:bodyPr wrap="square" lIns="0" tIns="0" rIns="0" bIns="0" rtlCol="0" anchor="ctr"/>
+          <a:lstStyle/>
+          <a:p>
+            <a:pPr indent="0" marL="0">
+              <a:buNone/>
+            </a:pPr>
+            <a:r>
+              <a:rPr lang="en-US" sz="1000" b="1" dirty="0">
                 <a:solidFill>
                   <a:srgbClr val="1C2933"/>
                 </a:solidFill>
@@ -10516,20 +10294,20 @@
               </a:rPr>
               <a:t>Placa educativa</a:t>
             </a:r>
-            <a:endParaRPr lang="en-US" sz="1050" dirty="0"/>
-          </a:p>
-        </p:txBody>
-      </p:sp>
-      <p:sp>
-        <p:nvSpPr>
-          <p:cNvPr id="18" name="Text 16"/>
-          <p:cNvSpPr/>
-          <p:nvPr/>
-        </p:nvSpPr>
-        <p:spPr>
-          <a:xfrm>
-            <a:off x="6099048" y="2414016"/>
-            <a:ext cx="1536192" cy="384048"/>
+            <a:endParaRPr lang="en-US" sz="1000" dirty="0"/>
+          </a:p>
+        </p:txBody>
+      </p:sp>
+      <p:sp>
+        <p:nvSpPr>
+          <p:cNvPr id="20" name="Text 16"/>
+          <p:cNvSpPr/>
+          <p:nvPr/>
+        </p:nvSpPr>
+        <p:spPr>
+          <a:xfrm>
+            <a:off x="6099048" y="2596896"/>
+            <a:ext cx="1536192" cy="237744"/>
           </a:xfrm>
           <a:prstGeom prst="rect">
             <a:avLst/>
@@ -10543,12 +10321,12 @@
           <a:p>
             <a:pPr indent="0" marL="0">
               <a:lnSpc>
-                <a:spcPts val="1100"/>
+                <a:spcPts val="1000"/>
               </a:lnSpc>
               <a:buNone/>
             </a:pPr>
             <a:r>
-              <a:rPr lang="en-US" sz="870" dirty="0">
+              <a:rPr lang="en-US" sz="830" dirty="0">
                 <a:solidFill>
                   <a:srgbClr val="5E6E77"/>
                 </a:solidFill>
@@ -10558,13 +10336,13 @@
               </a:rPr>
               <a:t>Sinalização fixa nas PNs críticas</a:t>
             </a:r>
-            <a:endParaRPr lang="en-US" sz="870" dirty="0"/>
-          </a:p>
-        </p:txBody>
-      </p:sp>
-      <p:sp>
-        <p:nvSpPr>
-          <p:cNvPr id="19" name="Shape 17"/>
+            <a:endParaRPr lang="en-US" sz="830" dirty="0"/>
+          </a:p>
+        </p:txBody>
+      </p:sp>
+      <p:sp>
+        <p:nvSpPr>
+          <p:cNvPr id="21" name="Shape 17"/>
           <p:cNvSpPr/>
           <p:nvPr/>
         </p:nvSpPr>
@@ -10589,32 +10367,56 @@
           </a:ln>
         </p:spPr>
       </p:sp>
-      <p:sp>
-        <p:nvSpPr>
-          <p:cNvPr id="20" name="Text 18"/>
-          <p:cNvSpPr/>
-          <p:nvPr/>
-        </p:nvSpPr>
-        <p:spPr>
-          <a:xfrm>
-            <a:off x="8037576" y="2139696"/>
-            <a:ext cx="1536192" cy="274320"/>
-          </a:xfrm>
-          <a:prstGeom prst="rect">
-            <a:avLst/>
-          </a:prstGeom>
-          <a:noFill/>
-          <a:ln/>
-        </p:spPr>
-        <p:txBody>
-          <a:bodyPr wrap="square" lIns="0" tIns="0" rIns="0" bIns="0" rtlCol="0" anchor="ctr"/>
-          <a:lstStyle/>
-          <a:p>
-            <a:pPr indent="0" marL="0">
-              <a:buNone/>
-            </a:pPr>
-            <a:r>
-              <a:rPr lang="en-US" sz="1050" b="1" dirty="0">
+      <p:pic>
+        <p:nvPicPr>
+          <p:cNvPr id="22" name="Image 2" descr="A:\Programas\PASTAS DO SISTEMA\claude\A--Documentos-Gest-o-de-Demandas\8ed8d158-bafd-4b35-b37c-d76ce293907f\scratchpad\vli-fonts\pptx_icons\mat_post.png">    </p:cNvPr>
+          <p:cNvPicPr>
+            <a:picLocks noChangeAspect="1"/>
+          </p:cNvPicPr>
+          <p:nvPr/>
+        </p:nvPicPr>
+        <p:blipFill>
+          <a:blip r:embed="rId3"/>
+          <a:stretch>
+            <a:fillRect/>
+          </a:stretch>
+        </p:blipFill>
+        <p:spPr>
+          <a:xfrm>
+            <a:off x="8037576" y="2121408"/>
+            <a:ext cx="201168" cy="201168"/>
+          </a:xfrm>
+          <a:prstGeom prst="rect">
+            <a:avLst/>
+          </a:prstGeom>
+        </p:spPr>
+      </p:pic>
+      <p:sp>
+        <p:nvSpPr>
+          <p:cNvPr id="23" name="Text 18"/>
+          <p:cNvSpPr/>
+          <p:nvPr/>
+        </p:nvSpPr>
+        <p:spPr>
+          <a:xfrm>
+            <a:off x="8037576" y="2359152"/>
+            <a:ext cx="1536192" cy="256032"/>
+          </a:xfrm>
+          <a:prstGeom prst="rect">
+            <a:avLst/>
+          </a:prstGeom>
+          <a:noFill/>
+          <a:ln/>
+        </p:spPr>
+        <p:txBody>
+          <a:bodyPr wrap="square" lIns="0" tIns="0" rIns="0" bIns="0" rtlCol="0" anchor="ctr"/>
+          <a:lstStyle/>
+          <a:p>
+            <a:pPr indent="0" marL="0">
+              <a:buNone/>
+            </a:pPr>
+            <a:r>
+              <a:rPr lang="en-US" sz="1000" b="1" dirty="0">
                 <a:solidFill>
                   <a:srgbClr val="1C2933"/>
                 </a:solidFill>
@@ -10624,20 +10426,20 @@
               </a:rPr>
               <a:t>Template de post</a:t>
             </a:r>
-            <a:endParaRPr lang="en-US" sz="1050" dirty="0"/>
-          </a:p>
-        </p:txBody>
-      </p:sp>
-      <p:sp>
-        <p:nvSpPr>
-          <p:cNvPr id="21" name="Text 19"/>
-          <p:cNvSpPr/>
-          <p:nvPr/>
-        </p:nvSpPr>
-        <p:spPr>
-          <a:xfrm>
-            <a:off x="8037576" y="2414016"/>
-            <a:ext cx="1536192" cy="384048"/>
+            <a:endParaRPr lang="en-US" sz="1000" dirty="0"/>
+          </a:p>
+        </p:txBody>
+      </p:sp>
+      <p:sp>
+        <p:nvSpPr>
+          <p:cNvPr id="24" name="Text 19"/>
+          <p:cNvSpPr/>
+          <p:nvPr/>
+        </p:nvSpPr>
+        <p:spPr>
+          <a:xfrm>
+            <a:off x="8037576" y="2596896"/>
+            <a:ext cx="1536192" cy="237744"/>
           </a:xfrm>
           <a:prstGeom prst="rect">
             <a:avLst/>
@@ -10651,12 +10453,12 @@
           <a:p>
             <a:pPr indent="0" marL="0">
               <a:lnSpc>
-                <a:spcPts val="1100"/>
+                <a:spcPts val="1000"/>
               </a:lnSpc>
               <a:buNone/>
             </a:pPr>
             <a:r>
-              <a:rPr lang="en-US" sz="870" dirty="0">
+              <a:rPr lang="en-US" sz="830" dirty="0">
                 <a:solidFill>
                   <a:srgbClr val="5E6E77"/>
                 </a:solidFill>
@@ -10666,13 +10468,13 @@
               </a:rPr>
               <a:t>Padrão comum de rede social</a:t>
             </a:r>
-            <a:endParaRPr lang="en-US" sz="870" dirty="0"/>
-          </a:p>
-        </p:txBody>
-      </p:sp>
-      <p:sp>
-        <p:nvSpPr>
-          <p:cNvPr id="22" name="Shape 20"/>
+            <a:endParaRPr lang="en-US" sz="830" dirty="0"/>
+          </a:p>
+        </p:txBody>
+      </p:sp>
+      <p:sp>
+        <p:nvSpPr>
+          <p:cNvPr id="25" name="Shape 20"/>
           <p:cNvSpPr/>
           <p:nvPr/>
         </p:nvSpPr>
@@ -10697,32 +10499,56 @@
           </a:ln>
         </p:spPr>
       </p:sp>
-      <p:sp>
-        <p:nvSpPr>
-          <p:cNvPr id="23" name="Text 21"/>
-          <p:cNvSpPr/>
-          <p:nvPr/>
-        </p:nvSpPr>
-        <p:spPr>
-          <a:xfrm>
-            <a:off x="4160520" y="3090672"/>
-            <a:ext cx="1536192" cy="274320"/>
-          </a:xfrm>
-          <a:prstGeom prst="rect">
-            <a:avLst/>
-          </a:prstGeom>
-          <a:noFill/>
-          <a:ln/>
-        </p:spPr>
-        <p:txBody>
-          <a:bodyPr wrap="square" lIns="0" tIns="0" rIns="0" bIns="0" rtlCol="0" anchor="ctr"/>
-          <a:lstStyle/>
-          <a:p>
-            <a:pPr indent="0" marL="0">
-              <a:buNone/>
-            </a:pPr>
-            <a:r>
-              <a:rPr lang="en-US" sz="1050" b="1" dirty="0">
+      <p:pic>
+        <p:nvPicPr>
+          <p:cNvPr id="26" name="Image 3" descr="A:\Programas\PASTAS DO SISTEMA\claude\A--Documentos-Gest-o-de-Demandas\8ed8d158-bafd-4b35-b37c-d76ce293907f\scratchpad\vli-fonts\pptx_icons\mat_backdrop.png">    </p:cNvPr>
+          <p:cNvPicPr>
+            <a:picLocks noChangeAspect="1"/>
+          </p:cNvPicPr>
+          <p:nvPr/>
+        </p:nvPicPr>
+        <p:blipFill>
+          <a:blip r:embed="rId4"/>
+          <a:stretch>
+            <a:fillRect/>
+          </a:stretch>
+        </p:blipFill>
+        <p:spPr>
+          <a:xfrm>
+            <a:off x="4160520" y="3072384"/>
+            <a:ext cx="201168" cy="201168"/>
+          </a:xfrm>
+          <a:prstGeom prst="rect">
+            <a:avLst/>
+          </a:prstGeom>
+        </p:spPr>
+      </p:pic>
+      <p:sp>
+        <p:nvSpPr>
+          <p:cNvPr id="27" name="Text 21"/>
+          <p:cNvSpPr/>
+          <p:nvPr/>
+        </p:nvSpPr>
+        <p:spPr>
+          <a:xfrm>
+            <a:off x="4160520" y="3310128"/>
+            <a:ext cx="1536192" cy="256032"/>
+          </a:xfrm>
+          <a:prstGeom prst="rect">
+            <a:avLst/>
+          </a:prstGeom>
+          <a:noFill/>
+          <a:ln/>
+        </p:spPr>
+        <p:txBody>
+          <a:bodyPr wrap="square" lIns="0" tIns="0" rIns="0" bIns="0" rtlCol="0" anchor="ctr"/>
+          <a:lstStyle/>
+          <a:p>
+            <a:pPr indent="0" marL="0">
+              <a:buNone/>
+            </a:pPr>
+            <a:r>
+              <a:rPr lang="en-US" sz="1000" b="1" dirty="0">
                 <a:solidFill>
                   <a:srgbClr val="1C2933"/>
                 </a:solidFill>
@@ -10732,20 +10558,20 @@
               </a:rPr>
               <a:t>Backdrop de coletiva</a:t>
             </a:r>
-            <a:endParaRPr lang="en-US" sz="1050" dirty="0"/>
-          </a:p>
-        </p:txBody>
-      </p:sp>
-      <p:sp>
-        <p:nvSpPr>
-          <p:cNvPr id="24" name="Text 22"/>
-          <p:cNvSpPr/>
-          <p:nvPr/>
-        </p:nvSpPr>
-        <p:spPr>
-          <a:xfrm>
-            <a:off x="4160520" y="3364992"/>
-            <a:ext cx="1536192" cy="384048"/>
+            <a:endParaRPr lang="en-US" sz="1000" dirty="0"/>
+          </a:p>
+        </p:txBody>
+      </p:sp>
+      <p:sp>
+        <p:nvSpPr>
+          <p:cNvPr id="28" name="Text 22"/>
+          <p:cNvSpPr/>
+          <p:nvPr/>
+        </p:nvSpPr>
+        <p:spPr>
+          <a:xfrm>
+            <a:off x="4160520" y="3547872"/>
+            <a:ext cx="1536192" cy="237744"/>
           </a:xfrm>
           <a:prstGeom prst="rect">
             <a:avLst/>
@@ -10759,12 +10585,12 @@
           <a:p>
             <a:pPr indent="0" marL="0">
               <a:lnSpc>
-                <a:spcPts val="1100"/>
+                <a:spcPts val="1000"/>
               </a:lnSpc>
               <a:buNone/>
             </a:pPr>
             <a:r>
-              <a:rPr lang="en-US" sz="870" dirty="0">
+              <a:rPr lang="en-US" sz="830" dirty="0">
                 <a:solidFill>
                   <a:srgbClr val="5E6E77"/>
                 </a:solidFill>
@@ -10774,13 +10600,13 @@
               </a:rPr>
               <a:t>Entrevistas do Dia D, todas as logos</a:t>
             </a:r>
-            <a:endParaRPr lang="en-US" sz="870" dirty="0"/>
-          </a:p>
-        </p:txBody>
-      </p:sp>
-      <p:sp>
-        <p:nvSpPr>
-          <p:cNvPr id="25" name="Shape 23"/>
+            <a:endParaRPr lang="en-US" sz="830" dirty="0"/>
+          </a:p>
+        </p:txBody>
+      </p:sp>
+      <p:sp>
+        <p:nvSpPr>
+          <p:cNvPr id="29" name="Shape 23"/>
           <p:cNvSpPr/>
           <p:nvPr/>
         </p:nvSpPr>
@@ -10805,32 +10631,56 @@
           </a:ln>
         </p:spPr>
       </p:sp>
-      <p:sp>
-        <p:nvSpPr>
-          <p:cNvPr id="26" name="Text 24"/>
-          <p:cNvSpPr/>
-          <p:nvPr/>
-        </p:nvSpPr>
-        <p:spPr>
-          <a:xfrm>
-            <a:off x="6099048" y="3090672"/>
-            <a:ext cx="1536192" cy="274320"/>
-          </a:xfrm>
-          <a:prstGeom prst="rect">
-            <a:avLst/>
-          </a:prstGeom>
-          <a:noFill/>
-          <a:ln/>
-        </p:spPr>
-        <p:txBody>
-          <a:bodyPr wrap="square" lIns="0" tIns="0" rIns="0" bIns="0" rtlCol="0" anchor="ctr"/>
-          <a:lstStyle/>
-          <a:p>
-            <a:pPr indent="0" marL="0">
-              <a:buNone/>
-            </a:pPr>
-            <a:r>
-              <a:rPr lang="en-US" sz="1050" b="1" dirty="0">
+      <p:pic>
+        <p:nvPicPr>
+          <p:cNvPr id="30" name="Image 4" descr="A:\Programas\PASTAS DO SISTEMA\claude\A--Documentos-Gest-o-de-Demandas\8ed8d158-bafd-4b35-b37c-d76ce293907f\scratchpad\vli-fonts\pptx_icons\mat_selo.png">    </p:cNvPr>
+          <p:cNvPicPr>
+            <a:picLocks noChangeAspect="1"/>
+          </p:cNvPicPr>
+          <p:nvPr/>
+        </p:nvPicPr>
+        <p:blipFill>
+          <a:blip r:embed="rId5"/>
+          <a:stretch>
+            <a:fillRect/>
+          </a:stretch>
+        </p:blipFill>
+        <p:spPr>
+          <a:xfrm>
+            <a:off x="6099048" y="3072384"/>
+            <a:ext cx="201168" cy="201168"/>
+          </a:xfrm>
+          <a:prstGeom prst="rect">
+            <a:avLst/>
+          </a:prstGeom>
+        </p:spPr>
+      </p:pic>
+      <p:sp>
+        <p:nvSpPr>
+          <p:cNvPr id="31" name="Text 24"/>
+          <p:cNvSpPr/>
+          <p:nvPr/>
+        </p:nvSpPr>
+        <p:spPr>
+          <a:xfrm>
+            <a:off x="6099048" y="3310128"/>
+            <a:ext cx="1536192" cy="256032"/>
+          </a:xfrm>
+          <a:prstGeom prst="rect">
+            <a:avLst/>
+          </a:prstGeom>
+          <a:noFill/>
+          <a:ln/>
+        </p:spPr>
+        <p:txBody>
+          <a:bodyPr wrap="square" lIns="0" tIns="0" rIns="0" bIns="0" rtlCol="0" anchor="ctr"/>
+          <a:lstStyle/>
+          <a:p>
+            <a:pPr indent="0" marL="0">
+              <a:buNone/>
+            </a:pPr>
+            <a:r>
+              <a:rPr lang="en-US" sz="1000" b="1" dirty="0">
                 <a:solidFill>
                   <a:srgbClr val="1C2933"/>
                 </a:solidFill>
@@ -10840,20 +10690,20 @@
               </a:rPr>
               <a:t>Selo do movimento</a:t>
             </a:r>
-            <a:endParaRPr lang="en-US" sz="1050" dirty="0"/>
-          </a:p>
-        </p:txBody>
-      </p:sp>
-      <p:sp>
-        <p:nvSpPr>
-          <p:cNvPr id="27" name="Text 25"/>
-          <p:cNvSpPr/>
-          <p:nvPr/>
-        </p:nvSpPr>
-        <p:spPr>
-          <a:xfrm>
-            <a:off x="6099048" y="3364992"/>
-            <a:ext cx="1536192" cy="384048"/>
+            <a:endParaRPr lang="en-US" sz="1000" dirty="0"/>
+          </a:p>
+        </p:txBody>
+      </p:sp>
+      <p:sp>
+        <p:nvSpPr>
+          <p:cNvPr id="32" name="Text 25"/>
+          <p:cNvSpPr/>
+          <p:nvPr/>
+        </p:nvSpPr>
+        <p:spPr>
+          <a:xfrm>
+            <a:off x="6099048" y="3547872"/>
+            <a:ext cx="1536192" cy="237744"/>
           </a:xfrm>
           <a:prstGeom prst="rect">
             <a:avLst/>
@@ -10867,12 +10717,12 @@
           <a:p>
             <a:pPr indent="0" marL="0">
               <a:lnSpc>
-                <a:spcPts val="1100"/>
+                <a:spcPts val="1000"/>
               </a:lnSpc>
               <a:buNone/>
             </a:pPr>
             <a:r>
-              <a:rPr lang="en-US" sz="870" dirty="0">
+              <a:rPr lang="en-US" sz="830" dirty="0">
                 <a:solidFill>
                   <a:srgbClr val="5E6E77"/>
                 </a:solidFill>
@@ -10882,13 +10732,13 @@
               </a:rPr>
               <a:t>Marca comum para identificar a campanha</a:t>
             </a:r>
-            <a:endParaRPr lang="en-US" sz="870" dirty="0"/>
-          </a:p>
-        </p:txBody>
-      </p:sp>
-      <p:sp>
-        <p:nvSpPr>
-          <p:cNvPr id="28" name="Shape 26"/>
+            <a:endParaRPr lang="en-US" sz="830" dirty="0"/>
+          </a:p>
+        </p:txBody>
+      </p:sp>
+      <p:sp>
+        <p:nvSpPr>
+          <p:cNvPr id="33" name="Shape 26"/>
           <p:cNvSpPr/>
           <p:nvPr/>
         </p:nvSpPr>
@@ -10913,32 +10763,56 @@
           </a:ln>
         </p:spPr>
       </p:sp>
-      <p:sp>
-        <p:nvSpPr>
-          <p:cNvPr id="29" name="Text 27"/>
-          <p:cNvSpPr/>
-          <p:nvPr/>
-        </p:nvSpPr>
-        <p:spPr>
-          <a:xfrm>
-            <a:off x="8037576" y="3090672"/>
-            <a:ext cx="1536192" cy="274320"/>
-          </a:xfrm>
-          <a:prstGeom prst="rect">
-            <a:avLst/>
-          </a:prstGeom>
-          <a:noFill/>
-          <a:ln/>
-        </p:spPr>
-        <p:txBody>
-          <a:bodyPr wrap="square" lIns="0" tIns="0" rIns="0" bIns="0" rtlCol="0" anchor="ctr"/>
-          <a:lstStyle/>
-          <a:p>
-            <a:pPr indent="0" marL="0">
-              <a:buNone/>
-            </a:pPr>
-            <a:r>
-              <a:rPr lang="en-US" sz="1050" b="1" dirty="0">
+      <p:pic>
+        <p:nvPicPr>
+          <p:cNvPr id="34" name="Image 5" descr="A:\Programas\PASTAS DO SISTEMA\claude\A--Documentos-Gest-o-de-Demandas\8ed8d158-bafd-4b35-b37c-d76ce293907f\scratchpad\vli-fonts\pptx_icons\mat_colete.png">    </p:cNvPr>
+          <p:cNvPicPr>
+            <a:picLocks noChangeAspect="1"/>
+          </p:cNvPicPr>
+          <p:nvPr/>
+        </p:nvPicPr>
+        <p:blipFill>
+          <a:blip r:embed="rId6"/>
+          <a:stretch>
+            <a:fillRect/>
+          </a:stretch>
+        </p:blipFill>
+        <p:spPr>
+          <a:xfrm>
+            <a:off x="8037576" y="3072384"/>
+            <a:ext cx="201168" cy="201168"/>
+          </a:xfrm>
+          <a:prstGeom prst="rect">
+            <a:avLst/>
+          </a:prstGeom>
+        </p:spPr>
+      </p:pic>
+      <p:sp>
+        <p:nvSpPr>
+          <p:cNvPr id="35" name="Text 27"/>
+          <p:cNvSpPr/>
+          <p:nvPr/>
+        </p:nvSpPr>
+        <p:spPr>
+          <a:xfrm>
+            <a:off x="8037576" y="3310128"/>
+            <a:ext cx="1536192" cy="256032"/>
+          </a:xfrm>
+          <a:prstGeom prst="rect">
+            <a:avLst/>
+          </a:prstGeom>
+          <a:noFill/>
+          <a:ln/>
+        </p:spPr>
+        <p:txBody>
+          <a:bodyPr wrap="square" lIns="0" tIns="0" rIns="0" bIns="0" rtlCol="0" anchor="ctr"/>
+          <a:lstStyle/>
+          <a:p>
+            <a:pPr indent="0" marL="0">
+              <a:buNone/>
+            </a:pPr>
+            <a:r>
+              <a:rPr lang="en-US" sz="1000" b="1" dirty="0">
                 <a:solidFill>
                   <a:srgbClr val="1C2933"/>
                 </a:solidFill>
@@ -10948,20 +10822,20 @@
               </a:rPr>
               <a:t>Colete de identificação</a:t>
             </a:r>
-            <a:endParaRPr lang="en-US" sz="1050" dirty="0"/>
-          </a:p>
-        </p:txBody>
-      </p:sp>
-      <p:sp>
-        <p:nvSpPr>
-          <p:cNvPr id="30" name="Text 28"/>
-          <p:cNvSpPr/>
-          <p:nvPr/>
-        </p:nvSpPr>
-        <p:spPr>
-          <a:xfrm>
-            <a:off x="8037576" y="3364992"/>
-            <a:ext cx="1536192" cy="384048"/>
+            <a:endParaRPr lang="en-US" sz="1000" dirty="0"/>
+          </a:p>
+        </p:txBody>
+      </p:sp>
+      <p:sp>
+        <p:nvSpPr>
+          <p:cNvPr id="36" name="Text 28"/>
+          <p:cNvSpPr/>
+          <p:nvPr/>
+        </p:nvSpPr>
+        <p:spPr>
+          <a:xfrm>
+            <a:off x="8037576" y="3547872"/>
+            <a:ext cx="1536192" cy="237744"/>
           </a:xfrm>
           <a:prstGeom prst="rect">
             <a:avLst/>
@@ -10975,12 +10849,12 @@
           <a:p>
             <a:pPr indent="0" marL="0">
               <a:lnSpc>
-                <a:spcPts val="1100"/>
+                <a:spcPts val="1000"/>
               </a:lnSpc>
               <a:buNone/>
             </a:pPr>
             <a:r>
-              <a:rPr lang="en-US" sz="870" dirty="0">
+              <a:rPr lang="en-US" sz="830" dirty="0">
                 <a:solidFill>
                   <a:srgbClr val="5E6E77"/>
                 </a:solidFill>
@@ -10990,13 +10864,13 @@
               </a:rPr>
               <a:t>Equipes de campo com identidade conjunta</a:t>
             </a:r>
-            <a:endParaRPr lang="en-US" sz="870" dirty="0"/>
-          </a:p>
-        </p:txBody>
-      </p:sp>
-      <p:sp>
-        <p:nvSpPr>
-          <p:cNvPr id="31" name="Shape 29"/>
+            <a:endParaRPr lang="en-US" sz="830" dirty="0"/>
+          </a:p>
+        </p:txBody>
+      </p:sp>
+      <p:sp>
+        <p:nvSpPr>
+          <p:cNvPr id="37" name="Shape 29"/>
           <p:cNvSpPr/>
           <p:nvPr/>
         </p:nvSpPr>
@@ -11018,7 +10892,7 @@
       </p:sp>
       <p:sp>
         <p:nvSpPr>
-          <p:cNvPr id="32" name="Text 30"/>
+          <p:cNvPr id="38" name="Text 30"/>
           <p:cNvSpPr/>
           <p:nvPr/>
         </p:nvSpPr>
@@ -11077,7 +10951,7 @@
       </p:sp>
       <p:sp>
         <p:nvSpPr>
-          <p:cNvPr id="33" name="Text 31"/>
+          <p:cNvPr id="39" name="Text 31"/>
           <p:cNvSpPr/>
           <p:nvPr/>
         </p:nvSpPr>
@@ -11116,7 +10990,7 @@
       </p:sp>
       <p:sp>
         <p:nvSpPr>
-          <p:cNvPr id="34" name="Text 32"/>
+          <p:cNvPr id="40" name="Text 32"/>
           <p:cNvSpPr/>
           <p:nvPr/>
         </p:nvSpPr>

</xml_diff>